<commit_message>
exercicio para os alunos
</commit_message>
<xml_diff>
--- a/slides/slice.pptx
+++ b/slides/slice.pptx
@@ -14,6 +14,10 @@
     <p:sldId id="262" r:id="rId8"/>
     <p:sldId id="263" r:id="rId9"/>
     <p:sldId id="264" r:id="rId10"/>
+    <p:sldId id="265" r:id="rId11"/>
+    <p:sldId id="268" r:id="rId12"/>
+    <p:sldId id="266" r:id="rId13"/>
+    <p:sldId id="267" r:id="rId14"/>
   </p:sldIdLst>
   <p:sldSz cx="12192000" cy="6858000"/>
   <p:notesSz cx="6858000" cy="9144000"/>
@@ -3017,6 +3021,262 @@
       </p:par>
     </p:tnLst>
   </p:timing>
+</p:sld>
+</file>
+
+<file path=ppt/slides/slide10.xml><?xml version="1.0" encoding="utf-8"?>
+<p:sld xmlns:a="http://schemas.openxmlformats.org/drawingml/2006/main" xmlns:r="http://schemas.openxmlformats.org/officeDocument/2006/relationships" xmlns:p="http://schemas.openxmlformats.org/presentationml/2006/main">
+  <p:cSld>
+    <p:spTree>
+      <p:nvGrpSpPr>
+        <p:cNvPr id="1" name=""/>
+        <p:cNvGrpSpPr/>
+        <p:nvPr/>
+      </p:nvGrpSpPr>
+      <p:grpSpPr>
+        <a:xfrm>
+          <a:off x="0" y="0"/>
+          <a:ext cx="0" cy="0"/>
+          <a:chOff x="0" y="0"/>
+          <a:chExt cx="0" cy="0"/>
+        </a:xfrm>
+      </p:grpSpPr>
+      <p:sp>
+        <p:nvSpPr>
+          <p:cNvPr id="2" name="Título 1"/>
+          <p:cNvSpPr>
+            <a:spLocks noGrp="1"/>
+          </p:cNvSpPr>
+          <p:nvPr>
+            <p:ph type="title"/>
+          </p:nvPr>
+        </p:nvSpPr>
+        <p:spPr/>
+        <p:txBody>
+          <a:bodyPr/>
+          <a:lstStyle/>
+          <a:p>
+            <a:r>
+              <a:rPr lang="pt-BR" dirty="0" smtClean="0"/>
+              <a:t>Exercícios</a:t>
+            </a:r>
+            <a:endParaRPr lang="pt-BR" dirty="0"/>
+          </a:p>
+        </p:txBody>
+      </p:sp>
+      <p:sp>
+        <p:nvSpPr>
+          <p:cNvPr id="3" name="Espaço Reservado para Conteúdo 2"/>
+          <p:cNvSpPr>
+            <a:spLocks noGrp="1"/>
+          </p:cNvSpPr>
+          <p:nvPr>
+            <p:ph idx="1"/>
+          </p:nvPr>
+        </p:nvSpPr>
+        <p:spPr/>
+        <p:txBody>
+          <a:bodyPr/>
+          <a:lstStyle/>
+          <a:p>
+            <a:endParaRPr lang="pt-BR" dirty="0"/>
+          </a:p>
+        </p:txBody>
+      </p:sp>
+    </p:spTree>
+    <p:extLst>
+      <p:ext uri="{BB962C8B-B14F-4D97-AF65-F5344CB8AC3E}">
+        <p14:creationId xmlns:p14="http://schemas.microsoft.com/office/powerpoint/2010/main" val="4286566442"/>
+      </p:ext>
+    </p:extLst>
+  </p:cSld>
+  <p:clrMapOvr>
+    <a:masterClrMapping/>
+  </p:clrMapOvr>
+</p:sld>
+</file>
+
+<file path=ppt/slides/slide11.xml><?xml version="1.0" encoding="utf-8"?>
+<p:sld xmlns:a="http://schemas.openxmlformats.org/drawingml/2006/main" xmlns:r="http://schemas.openxmlformats.org/officeDocument/2006/relationships" xmlns:p="http://schemas.openxmlformats.org/presentationml/2006/main">
+  <p:cSld>
+    <p:spTree>
+      <p:nvGrpSpPr>
+        <p:cNvPr id="1" name=""/>
+        <p:cNvGrpSpPr/>
+        <p:nvPr/>
+      </p:nvGrpSpPr>
+      <p:grpSpPr>
+        <a:xfrm>
+          <a:off x="0" y="0"/>
+          <a:ext cx="0" cy="0"/>
+          <a:chOff x="0" y="0"/>
+          <a:chExt cx="0" cy="0"/>
+        </a:xfrm>
+      </p:grpSpPr>
+      <p:sp>
+        <p:nvSpPr>
+          <p:cNvPr id="2" name="Título 1"/>
+          <p:cNvSpPr>
+            <a:spLocks noGrp="1"/>
+          </p:cNvSpPr>
+          <p:nvPr>
+            <p:ph type="title"/>
+          </p:nvPr>
+        </p:nvSpPr>
+        <p:spPr/>
+        <p:txBody>
+          <a:bodyPr/>
+          <a:lstStyle/>
+          <a:p>
+            <a:r>
+              <a:rPr lang="pt-BR" dirty="0" smtClean="0"/>
+              <a:t>Projeto Integrador</a:t>
+            </a:r>
+            <a:endParaRPr lang="pt-BR" dirty="0"/>
+          </a:p>
+        </p:txBody>
+      </p:sp>
+      <p:sp>
+        <p:nvSpPr>
+          <p:cNvPr id="3" name="Espaço Reservado para Conteúdo 2"/>
+          <p:cNvSpPr>
+            <a:spLocks noGrp="1"/>
+          </p:cNvSpPr>
+          <p:nvPr>
+            <p:ph idx="1"/>
+          </p:nvPr>
+        </p:nvSpPr>
+        <p:spPr/>
+        <p:txBody>
+          <a:bodyPr/>
+          <a:lstStyle/>
+          <a:p>
+            <a:r>
+              <a:rPr lang="pt-BR" dirty="0" err="1" smtClean="0"/>
+              <a:t>Braimstorm</a:t>
+            </a:r>
+            <a:endParaRPr lang="pt-BR" dirty="0"/>
+          </a:p>
+        </p:txBody>
+      </p:sp>
+      <p:pic>
+        <p:nvPicPr>
+          <p:cNvPr id="4" name="Imagem 3"/>
+          <p:cNvPicPr>
+            <a:picLocks noChangeAspect="1"/>
+          </p:cNvPicPr>
+          <p:nvPr/>
+        </p:nvPicPr>
+        <p:blipFill>
+          <a:blip r:embed="rId2"/>
+          <a:stretch>
+            <a:fillRect/>
+          </a:stretch>
+        </p:blipFill>
+        <p:spPr>
+          <a:xfrm>
+            <a:off x="838200" y="2677756"/>
+            <a:ext cx="4443904" cy="2647076"/>
+          </a:xfrm>
+          <a:prstGeom prst="rect">
+            <a:avLst/>
+          </a:prstGeom>
+        </p:spPr>
+      </p:pic>
+      <p:pic>
+        <p:nvPicPr>
+          <p:cNvPr id="5" name="Imagem 4"/>
+          <p:cNvPicPr>
+            <a:picLocks noChangeAspect="1"/>
+          </p:cNvPicPr>
+          <p:nvPr/>
+        </p:nvPicPr>
+        <p:blipFill>
+          <a:blip r:embed="rId3"/>
+          <a:stretch>
+            <a:fillRect/>
+          </a:stretch>
+        </p:blipFill>
+        <p:spPr>
+          <a:xfrm>
+            <a:off x="5560196" y="2677756"/>
+            <a:ext cx="3990975" cy="1219200"/>
+          </a:xfrm>
+          <a:prstGeom prst="rect">
+            <a:avLst/>
+          </a:prstGeom>
+        </p:spPr>
+      </p:pic>
+    </p:spTree>
+    <p:extLst>
+      <p:ext uri="{BB962C8B-B14F-4D97-AF65-F5344CB8AC3E}">
+        <p14:creationId xmlns:p14="http://schemas.microsoft.com/office/powerpoint/2010/main" val="3754120042"/>
+      </p:ext>
+    </p:extLst>
+  </p:cSld>
+  <p:clrMapOvr>
+    <a:masterClrMapping/>
+  </p:clrMapOvr>
+</p:sld>
+</file>
+
+<file path=ppt/slides/slide12.xml><?xml version="1.0" encoding="utf-8"?>
+<p:sld xmlns:a="http://schemas.openxmlformats.org/drawingml/2006/main" xmlns:r="http://schemas.openxmlformats.org/officeDocument/2006/relationships" xmlns:p="http://schemas.openxmlformats.org/presentationml/2006/main">
+  <p:cSld>
+    <p:spTree>
+      <p:nvGrpSpPr>
+        <p:cNvPr id="1" name=""/>
+        <p:cNvGrpSpPr/>
+        <p:nvPr/>
+      </p:nvGrpSpPr>
+      <p:grpSpPr>
+        <a:xfrm>
+          <a:off x="0" y="0"/>
+          <a:ext cx="0" cy="0"/>
+          <a:chOff x="0" y="0"/>
+          <a:chExt cx="0" cy="0"/>
+        </a:xfrm>
+      </p:grpSpPr>
+    </p:spTree>
+    <p:extLst>
+      <p:ext uri="{BB962C8B-B14F-4D97-AF65-F5344CB8AC3E}">
+        <p14:creationId xmlns:p14="http://schemas.microsoft.com/office/powerpoint/2010/main" val="2420052725"/>
+      </p:ext>
+    </p:extLst>
+  </p:cSld>
+  <p:clrMapOvr>
+    <a:masterClrMapping/>
+  </p:clrMapOvr>
+</p:sld>
+</file>
+
+<file path=ppt/slides/slide13.xml><?xml version="1.0" encoding="utf-8"?>
+<p:sld xmlns:a="http://schemas.openxmlformats.org/drawingml/2006/main" xmlns:r="http://schemas.openxmlformats.org/officeDocument/2006/relationships" xmlns:p="http://schemas.openxmlformats.org/presentationml/2006/main">
+  <p:cSld>
+    <p:spTree>
+      <p:nvGrpSpPr>
+        <p:cNvPr id="1" name=""/>
+        <p:cNvGrpSpPr/>
+        <p:nvPr/>
+      </p:nvGrpSpPr>
+      <p:grpSpPr>
+        <a:xfrm>
+          <a:off x="0" y="0"/>
+          <a:ext cx="0" cy="0"/>
+          <a:chOff x="0" y="0"/>
+          <a:chExt cx="0" cy="0"/>
+        </a:xfrm>
+      </p:grpSpPr>
+    </p:spTree>
+    <p:extLst>
+      <p:ext uri="{BB962C8B-B14F-4D97-AF65-F5344CB8AC3E}">
+        <p14:creationId xmlns:p14="http://schemas.microsoft.com/office/powerpoint/2010/main" val="3770872025"/>
+      </p:ext>
+    </p:extLst>
+  </p:cSld>
+  <p:clrMapOvr>
+    <a:masterClrMapping/>
+  </p:clrMapOvr>
 </p:sld>
 </file>
 
@@ -3562,8 +3822,32 @@
         </p:blipFill>
         <p:spPr>
           <a:xfrm>
-            <a:off x="838200" y="1481705"/>
-            <a:ext cx="6438900" cy="4800600"/>
+            <a:off x="720754" y="1599151"/>
+            <a:ext cx="3347906" cy="2496072"/>
+          </a:xfrm>
+          <a:prstGeom prst="rect">
+            <a:avLst/>
+          </a:prstGeom>
+        </p:spPr>
+      </p:pic>
+      <p:pic>
+        <p:nvPicPr>
+          <p:cNvPr id="5" name="Imagem 4"/>
+          <p:cNvPicPr>
+            <a:picLocks noChangeAspect="1"/>
+          </p:cNvPicPr>
+          <p:nvPr/>
+        </p:nvPicPr>
+        <p:blipFill>
+          <a:blip r:embed="rId3"/>
+          <a:stretch>
+            <a:fillRect/>
+          </a:stretch>
+        </p:blipFill>
+        <p:spPr>
+          <a:xfrm>
+            <a:off x="5319538" y="1690688"/>
+            <a:ext cx="6260765" cy="4985027"/>
           </a:xfrm>
           <a:prstGeom prst="rect">
             <a:avLst/>
@@ -4009,6 +4293,13 @@
   <p:clrMapOvr>
     <a:masterClrMapping/>
   </p:clrMapOvr>
+  <p:timing>
+    <p:tnLst>
+      <p:par>
+        <p:cTn id="1" dur="indefinite" restart="never" nodeType="tmRoot"/>
+      </p:par>
+    </p:tnLst>
+  </p:timing>
 </p:sld>
 </file>
 

</xml_diff>